<commit_message>
docs(assets): regenerate all 12 assets with BeyondNet dark/gold identity and conceptual diagrams
</commit_message>
<xml_diff>
--- a/reference/governance/sdlc/assets/evolith-sdlc-technical-deepdive.pptx
+++ b/reference/governance/sdlc/assets/evolith-sdlc-technical-deepdive.pptx
@@ -8,13 +8,8 @@
     <p:sldId id="256" r:id="rId7"/>
     <p:sldId id="257" r:id="rId8"/>
     <p:sldId id="258" r:id="rId9"/>
-    <p:sldId id="259" r:id="rId10"/>
-    <p:sldId id="260" r:id="rId11"/>
-    <p:sldId id="261" r:id="rId12"/>
-    <p:sldId id="262" r:id="rId13"/>
-    <p:sldId id="263" r:id="rId14"/>
   </p:sldIdLst>
-  <p:sldSz cx="12191695" cy="6858000" type="screen4x3"/>
+  <p:sldSz cx="9144000" cy="6858000" type="screen4x3"/>
   <p:notesSz cx="6858000" cy="9144000"/>
   <p:defaultTextStyle>
     <a:defPPr>
@@ -3088,6 +3083,14 @@
 <file path=ppt/slides/slide1.xml><?xml version="1.0" encoding="utf-8"?>
 <p:sld xmlns:a="http://schemas.openxmlformats.org/drawingml/2006/main" xmlns:p="http://schemas.openxmlformats.org/presentationml/2006/main" xmlns:r="http://schemas.openxmlformats.org/officeDocument/2006/relationships">
   <p:cSld>
+    <p:bg>
+      <p:bgPr>
+        <a:solidFill>
+          <a:srgbClr val="121212"/>
+        </a:solidFill>
+        <a:effectLst/>
+      </p:bgPr>
+    </p:bg>
     <p:spTree>
       <p:nvGrpSpPr>
         <p:cNvPr id="1" name=""/>
@@ -3097,24 +3100,109 @@
       <p:grpSpPr/>
       <p:sp>
         <p:nvSpPr>
-          <p:cNvPr id="2" name="Rectangle 1"/>
-          <p:cNvSpPr/>
-          <p:nvPr/>
+          <p:cNvPr id="2" name="Title 1"/>
+          <p:cNvSpPr>
+            <a:spLocks noGrp="1"/>
+          </p:cNvSpPr>
+          <p:nvPr>
+            <p:ph type="ctrTitle"/>
+          </p:nvPr>
         </p:nvSpPr>
         <p:spPr>
           <a:xfrm>
-            <a:off x="0" y="0"/>
-            <a:ext cx="12191695" cy="6858000"/>
+            <a:off x="457200" y="457200"/>
+            <a:ext cx="8229600" cy="914400"/>
+          </a:xfrm>
+        </p:spPr>
+        <p:txBody>
+          <a:bodyPr/>
+          <a:lstStyle/>
+          <a:p>
+            <a:pPr algn="l"/>
+            <a:r>
+              <a:rPr sz="3600" b="1">
+                <a:solidFill>
+                  <a:srgbClr val="CAC5B2"/>
+                </a:solidFill>
+              </a:rPr>
+              <a:t>Evolith SDLC: Deep-Dive Técnico</a:t>
+            </a:r>
+          </a:p>
+        </p:txBody>
+      </p:sp>
+      <p:sp>
+        <p:nvSpPr>
+          <p:cNvPr id="3" name="Subtitle 2"/>
+          <p:cNvSpPr>
+            <a:spLocks noGrp="1"/>
+          </p:cNvSpPr>
+          <p:nvPr>
+            <p:ph type="subTitle" idx="1"/>
+          </p:nvPr>
+        </p:nvSpPr>
+        <p:spPr/>
+        <p:txBody>
+          <a:bodyPr/>
+          <a:lstStyle/>
+          <a:p/>
+        </p:txBody>
+      </p:sp>
+      <p:sp>
+        <p:nvSpPr>
+          <p:cNvPr id="4" name="TextBox 3"/>
+          <p:cNvSpPr txBox="1"/>
+          <p:nvPr/>
+        </p:nvSpPr>
+        <p:spPr>
+          <a:xfrm>
+            <a:off x="457200" y="1828800"/>
+            <a:ext cx="8229600" cy="1371600"/>
           </a:xfrm>
           <a:prstGeom prst="rect">
             <a:avLst/>
           </a:prstGeom>
+          <a:noFill/>
+        </p:spPr>
+        <p:txBody>
+          <a:bodyPr wrap="none">
+            <a:spAutoFit/>
+          </a:bodyPr>
+          <a:lstStyle/>
+          <a:p/>
+          <a:p>
+            <a:pPr>
+              <a:defRPr sz="2400">
+                <a:solidFill>
+                  <a:srgbClr val="FFFFFF"/>
+                </a:solidFill>
+              </a:defRPr>
+            </a:pPr>
+            <a:r>
+              <a:t>Diagramas de Arquitectura y Pipeline</a:t>
+            </a:r>
+          </a:p>
+        </p:txBody>
+      </p:sp>
+      <p:sp>
+        <p:nvSpPr>
+          <p:cNvPr id="5" name="Rounded Rectangle 4"/>
+          <p:cNvSpPr/>
+          <p:nvPr/>
+        </p:nvSpPr>
+        <p:spPr>
+          <a:xfrm>
+            <a:off x="3657600" y="3657600"/>
+            <a:ext cx="1828800" cy="1828800"/>
+          </a:xfrm>
+          <a:prstGeom prst="roundRect">
+            <a:avLst/>
+          </a:prstGeom>
           <a:solidFill>
-            <a:srgbClr val="1E3A5F"/>
+            <a:srgbClr val="121212"/>
           </a:solidFill>
-          <a:ln>
+          <a:ln w="25400">
             <a:solidFill>
-              <a:srgbClr val="1E3A5F"/>
+              <a:srgbClr val="CAC5B2"/>
             </a:solidFill>
           </a:ln>
         </p:spPr>
@@ -3137,29 +3225,72 @@
           <a:lstStyle/>
           <a:p>
             <a:pPr algn="ctr"/>
-          </a:p>
-        </p:txBody>
-      </p:sp>
-      <p:sp>
-        <p:nvSpPr>
-          <p:cNvPr id="3" name="Rectangle 2"/>
+            <a:r>
+              <a:rPr sz="1400" b="1">
+                <a:solidFill>
+                  <a:srgbClr val="121212"/>
+                </a:solidFill>
+              </a:rPr>
+              <a:t>EVOLITH</a:t>
+            </a:r>
+          </a:p>
+          <a:p>
+            <a:pPr algn="ctr"/>
+            <a:r>
+              <a:rPr sz="1400" b="1">
+                <a:solidFill>
+                  <a:srgbClr val="121212"/>
+                </a:solidFill>
+              </a:rPr>
+              <a:t>CORE</a:t>
+            </a:r>
+          </a:p>
+        </p:txBody>
+      </p:sp>
+    </p:spTree>
+  </p:cSld>
+  <p:clrMapOvr>
+    <a:masterClrMapping/>
+  </p:clrMapOvr>
+</p:sld>
+</file>
+
+<file path=ppt/slides/slide2.xml><?xml version="1.0" encoding="utf-8"?>
+<p:sld xmlns:a="http://schemas.openxmlformats.org/drawingml/2006/main" xmlns:p="http://schemas.openxmlformats.org/presentationml/2006/main" xmlns:r="http://schemas.openxmlformats.org/officeDocument/2006/relationships">
+  <p:cSld>
+    <p:bg>
+      <p:bgPr>
+        <a:solidFill>
+          <a:srgbClr val="121212"/>
+        </a:solidFill>
+        <a:effectLst/>
+      </p:bgPr>
+    </p:bg>
+    <p:spTree>
+      <p:nvGrpSpPr>
+        <p:cNvPr id="1" name=""/>
+        <p:cNvGrpSpPr/>
+        <p:nvPr/>
+      </p:nvGrpSpPr>
+      <p:grpSpPr/>
+      <p:sp>
+        <p:nvSpPr>
+          <p:cNvPr id="2" name="Rounded Rectangle 1"/>
           <p:cNvSpPr/>
           <p:nvPr/>
         </p:nvSpPr>
         <p:spPr>
           <a:xfrm>
-            <a:off x="0" y="6400800"/>
-            <a:ext cx="12191695" cy="457200"/>
+            <a:off x="457200" y="2743200"/>
+            <a:ext cx="1371600" cy="914400"/>
           </a:xfrm>
-          <a:prstGeom prst="rect">
+          <a:prstGeom prst="roundRect">
             <a:avLst/>
           </a:prstGeom>
-          <a:solidFill>
-            <a:srgbClr val="3B82F6"/>
-          </a:solidFill>
-          <a:ln>
+          <a:noFill/>
+          <a:ln w="25400">
             <a:solidFill>
-              <a:srgbClr val="3B82F6"/>
+              <a:srgbClr val="FFFFFF"/>
             </a:solidFill>
           </a:ln>
         </p:spPr>
@@ -3182,97 +3313,37 @@
           <a:lstStyle/>
           <a:p>
             <a:pPr algn="ctr"/>
-          </a:p>
-        </p:txBody>
-      </p:sp>
-      <p:sp>
-        <p:nvSpPr>
-          <p:cNvPr id="4" name="TextBox 3"/>
-          <p:cNvSpPr txBox="1"/>
-          <p:nvPr/>
-        </p:nvSpPr>
-        <p:spPr>
-          <a:xfrm>
-            <a:off x="914400" y="2286000"/>
-            <a:ext cx="10362895" cy="1828800"/>
-          </a:xfrm>
-          <a:prstGeom prst="rect">
-            <a:avLst/>
-          </a:prstGeom>
-          <a:noFill/>
-        </p:spPr>
-        <p:txBody>
-          <a:bodyPr wrap="square">
-            <a:spAutoFit/>
-          </a:bodyPr>
-          <a:lstStyle/>
-          <a:p>
-            <a:pPr>
-              <a:defRPr b="1" sz="5000">
+            <a:r>
+              <a:rPr sz="1400" b="1">
                 <a:solidFill>
                   <a:srgbClr val="FFFFFF"/>
                 </a:solidFill>
-              </a:defRPr>
-            </a:pPr>
-            <a:r>
-              <a:t>Deep-Dive SDLC: Fases y Artefactos</a:t>
-            </a:r>
-          </a:p>
-          <a:p>
-            <a:pPr>
-              <a:spcBef>
-                <a:spcPts val="1400"/>
-              </a:spcBef>
-              <a:defRPr sz="2400">
-                <a:solidFill>
-                  <a:srgbClr val="3B82F6"/>
-                </a:solidFill>
-              </a:defRPr>
-            </a:pPr>
-            <a:r>
-              <a:t>Guía operativa de Ingeniería.</a:t>
-            </a:r>
-          </a:p>
-        </p:txBody>
-      </p:sp>
-    </p:spTree>
-  </p:cSld>
-  <p:clrMapOvr>
-    <a:masterClrMapping/>
-  </p:clrMapOvr>
-</p:sld>
-</file>
-
-<file path=ppt/slides/slide2.xml><?xml version="1.0" encoding="utf-8"?>
-<p:sld xmlns:a="http://schemas.openxmlformats.org/drawingml/2006/main" xmlns:p="http://schemas.openxmlformats.org/presentationml/2006/main" xmlns:r="http://schemas.openxmlformats.org/officeDocument/2006/relationships">
-  <p:cSld>
-    <p:spTree>
-      <p:nvGrpSpPr>
-        <p:cNvPr id="1" name=""/>
-        <p:cNvGrpSpPr/>
-        <p:nvPr/>
-      </p:nvGrpSpPr>
-      <p:grpSpPr/>
-      <p:sp>
-        <p:nvSpPr>
-          <p:cNvPr id="2" name="Rectangle 1"/>
+              </a:rPr>
+              <a:t>Git Push</a:t>
+            </a:r>
+          </a:p>
+        </p:txBody>
+      </p:sp>
+      <p:sp>
+        <p:nvSpPr>
+          <p:cNvPr id="3" name="Right Arrow 2"/>
           <p:cNvSpPr/>
           <p:nvPr/>
         </p:nvSpPr>
         <p:spPr>
           <a:xfrm>
-            <a:off x="0" y="0"/>
-            <a:ext cx="12191695" cy="1097280"/>
+            <a:off x="1920240" y="3017520"/>
+            <a:ext cx="365760" cy="365760"/>
           </a:xfrm>
-          <a:prstGeom prst="rect">
+          <a:prstGeom prst="rightArrow">
             <a:avLst/>
           </a:prstGeom>
           <a:solidFill>
-            <a:srgbClr val="1E3A5F"/>
+            <a:srgbClr val="CAC5B2"/>
           </a:solidFill>
           <a:ln>
             <a:solidFill>
-              <a:srgbClr val="1E3A5F"/>
+              <a:srgbClr val="CAC5B2"/>
             </a:solidFill>
           </a:ln>
         </p:spPr>
@@ -3300,24 +3371,22 @@
       </p:sp>
       <p:sp>
         <p:nvSpPr>
-          <p:cNvPr id="3" name="Rectangle 2"/>
+          <p:cNvPr id="4" name="Rounded Rectangle 3"/>
           <p:cNvSpPr/>
           <p:nvPr/>
         </p:nvSpPr>
         <p:spPr>
           <a:xfrm>
-            <a:off x="0" y="1097280"/>
-            <a:ext cx="12191695" cy="91440"/>
+            <a:off x="2377440" y="2743200"/>
+            <a:ext cx="1371600" cy="914400"/>
           </a:xfrm>
-          <a:prstGeom prst="rect">
+          <a:prstGeom prst="roundRect">
             <a:avLst/>
           </a:prstGeom>
-          <a:solidFill>
-            <a:srgbClr val="3B82F6"/>
-          </a:solidFill>
-          <a:ln>
+          <a:noFill/>
+          <a:ln w="25400">
             <a:solidFill>
-              <a:srgbClr val="3B82F6"/>
+              <a:srgbClr val="FFFFFF"/>
             </a:solidFill>
           </a:ln>
         </p:spPr>
@@ -3340,117 +3409,37 @@
           <a:lstStyle/>
           <a:p>
             <a:pPr algn="ctr"/>
-          </a:p>
-        </p:txBody>
-      </p:sp>
-      <p:sp>
-        <p:nvSpPr>
-          <p:cNvPr id="4" name="TextBox 3"/>
-          <p:cNvSpPr txBox="1"/>
-          <p:nvPr/>
-        </p:nvSpPr>
-        <p:spPr>
-          <a:xfrm>
-            <a:off x="457200" y="91440"/>
-            <a:ext cx="11277295" cy="914400"/>
-          </a:xfrm>
-          <a:prstGeom prst="rect">
-            <a:avLst/>
-          </a:prstGeom>
-          <a:noFill/>
-        </p:spPr>
-        <p:txBody>
-          <a:bodyPr wrap="none">
-            <a:spAutoFit/>
-          </a:bodyPr>
-          <a:lstStyle/>
-          <a:p>
-            <a:pPr>
-              <a:defRPr b="1" sz="3600">
+            <a:r>
+              <a:rPr sz="1400" b="1">
                 <a:solidFill>
                   <a:srgbClr val="FFFFFF"/>
                 </a:solidFill>
-              </a:defRPr>
-            </a:pPr>
-            <a:r>
-              <a:t>El Ciclo de Vida Evolith (8 Fases)</a:t>
-            </a:r>
-          </a:p>
-        </p:txBody>
-      </p:sp>
-      <p:sp>
-        <p:nvSpPr>
-          <p:cNvPr id="5" name="TextBox 4"/>
-          <p:cNvSpPr txBox="1"/>
+              </a:rPr>
+              <a:t>Build</a:t>
+            </a:r>
+          </a:p>
+        </p:txBody>
+      </p:sp>
+      <p:sp>
+        <p:nvSpPr>
+          <p:cNvPr id="5" name="Right Arrow 4"/>
+          <p:cNvSpPr/>
           <p:nvPr/>
         </p:nvSpPr>
         <p:spPr>
           <a:xfrm>
-            <a:off x="457200" y="1645920"/>
-            <a:ext cx="11277295" cy="5029200"/>
+            <a:off x="3840480" y="3017520"/>
+            <a:ext cx="365760" cy="365760"/>
           </a:xfrm>
-          <a:prstGeom prst="rect">
-            <a:avLst/>
-          </a:prstGeom>
-          <a:noFill/>
-        </p:spPr>
-        <p:txBody>
-          <a:bodyPr wrap="square">
-            <a:spAutoFit/>
-          </a:bodyPr>
-          <a:lstStyle/>
-          <a:p>
-            <a:pPr>
-              <a:defRPr sz="2200">
-                <a:solidFill>
-                  <a:srgbClr val="323232"/>
-                </a:solidFill>
-              </a:defRPr>
-            </a:pPr>
-            <a:r>
-              <a:t>F1 Ideación -&gt; F2 Análisis -&gt; F3 Diseño -&gt; F4 Construcción -&gt; F5 Pruebas -&gt; F6 Despliegue -&gt; F7 Operación -&gt; F8 Retiro.</a:t>
-            </a:r>
-          </a:p>
-        </p:txBody>
-      </p:sp>
-    </p:spTree>
-  </p:cSld>
-  <p:clrMapOvr>
-    <a:masterClrMapping/>
-  </p:clrMapOvr>
-</p:sld>
-</file>
-
-<file path=ppt/slides/slide3.xml><?xml version="1.0" encoding="utf-8"?>
-<p:sld xmlns:a="http://schemas.openxmlformats.org/drawingml/2006/main" xmlns:p="http://schemas.openxmlformats.org/presentationml/2006/main" xmlns:r="http://schemas.openxmlformats.org/officeDocument/2006/relationships">
-  <p:cSld>
-    <p:spTree>
-      <p:nvGrpSpPr>
-        <p:cNvPr id="1" name=""/>
-        <p:cNvGrpSpPr/>
-        <p:nvPr/>
-      </p:nvGrpSpPr>
-      <p:grpSpPr/>
-      <p:sp>
-        <p:nvSpPr>
-          <p:cNvPr id="2" name="Rectangle 1"/>
-          <p:cNvSpPr/>
-          <p:nvPr/>
-        </p:nvSpPr>
-        <p:spPr>
-          <a:xfrm>
-            <a:off x="0" y="0"/>
-            <a:ext cx="12191695" cy="1097280"/>
-          </a:xfrm>
-          <a:prstGeom prst="rect">
+          <a:prstGeom prst="rightArrow">
             <a:avLst/>
           </a:prstGeom>
           <a:solidFill>
-            <a:srgbClr val="1E3A5F"/>
+            <a:srgbClr val="CAC5B2"/>
           </a:solidFill>
           <a:ln>
             <a:solidFill>
-              <a:srgbClr val="1E3A5F"/>
+              <a:srgbClr val="CAC5B2"/>
             </a:solidFill>
           </a:ln>
         </p:spPr>
@@ -3478,24 +3467,24 @@
       </p:sp>
       <p:sp>
         <p:nvSpPr>
-          <p:cNvPr id="3" name="Rectangle 2"/>
+          <p:cNvPr id="6" name="Rounded Rectangle 5"/>
           <p:cNvSpPr/>
           <p:nvPr/>
         </p:nvSpPr>
         <p:spPr>
           <a:xfrm>
-            <a:off x="0" y="1097280"/>
-            <a:ext cx="12191695" cy="91440"/>
+            <a:off x="4297680" y="2286000"/>
+            <a:ext cx="1371600" cy="1828800"/>
           </a:xfrm>
-          <a:prstGeom prst="rect">
+          <a:prstGeom prst="roundRect">
             <a:avLst/>
           </a:prstGeom>
           <a:solidFill>
-            <a:srgbClr val="3B82F6"/>
+            <a:srgbClr val="CAC5B2"/>
           </a:solidFill>
-          <a:ln>
+          <a:ln w="25400">
             <a:solidFill>
-              <a:srgbClr val="3B82F6"/>
+              <a:srgbClr val="121212"/>
             </a:solidFill>
           </a:ln>
         </p:spPr>
@@ -3518,147 +3507,48 @@
           <a:lstStyle/>
           <a:p>
             <a:pPr algn="ctr"/>
-          </a:p>
-        </p:txBody>
-      </p:sp>
-      <p:sp>
-        <p:nvSpPr>
-          <p:cNvPr id="4" name="TextBox 3"/>
-          <p:cNvSpPr txBox="1"/>
+            <a:r>
+              <a:rPr sz="1400" b="1">
+                <a:solidFill>
+                  <a:srgbClr val="121212"/>
+                </a:solidFill>
+              </a:rPr>
+              <a:t>SAST Scan</a:t>
+            </a:r>
+          </a:p>
+          <a:p>
+            <a:pPr algn="ctr"/>
+            <a:r>
+              <a:rPr sz="1400" b="1">
+                <a:solidFill>
+                  <a:srgbClr val="121212"/>
+                </a:solidFill>
+              </a:rPr>
+              <a:t>Quality Gate</a:t>
+            </a:r>
+          </a:p>
+        </p:txBody>
+      </p:sp>
+      <p:sp>
+        <p:nvSpPr>
+          <p:cNvPr id="7" name="Right Arrow 6"/>
+          <p:cNvSpPr/>
           <p:nvPr/>
         </p:nvSpPr>
         <p:spPr>
           <a:xfrm>
-            <a:off x="457200" y="91440"/>
-            <a:ext cx="11277295" cy="914400"/>
+            <a:off x="5760720" y="3017520"/>
+            <a:ext cx="365760" cy="365760"/>
           </a:xfrm>
-          <a:prstGeom prst="rect">
-            <a:avLst/>
-          </a:prstGeom>
-          <a:noFill/>
-        </p:spPr>
-        <p:txBody>
-          <a:bodyPr wrap="none">
-            <a:spAutoFit/>
-          </a:bodyPr>
-          <a:lstStyle/>
-          <a:p>
-            <a:pPr>
-              <a:defRPr b="1" sz="3600">
-                <a:solidFill>
-                  <a:srgbClr val="FFFFFF"/>
-                </a:solidFill>
-              </a:defRPr>
-            </a:pPr>
-            <a:r>
-              <a:t>Ideación y Análisis</a:t>
-            </a:r>
-          </a:p>
-        </p:txBody>
-      </p:sp>
-      <p:sp>
-        <p:nvSpPr>
-          <p:cNvPr id="5" name="TextBox 4"/>
-          <p:cNvSpPr txBox="1"/>
-          <p:nvPr/>
-        </p:nvSpPr>
-        <p:spPr>
-          <a:xfrm>
-            <a:off x="457200" y="1645920"/>
-            <a:ext cx="11277295" cy="5029200"/>
-          </a:xfrm>
-          <a:prstGeom prst="rect">
-            <a:avLst/>
-          </a:prstGeom>
-          <a:noFill/>
-        </p:spPr>
-        <p:txBody>
-          <a:bodyPr wrap="square">
-            <a:spAutoFit/>
-          </a:bodyPr>
-          <a:lstStyle/>
-          <a:p>
-            <a:pPr>
-              <a:defRPr sz="2200">
-                <a:solidFill>
-                  <a:srgbClr val="323232"/>
-                </a:solidFill>
-              </a:defRPr>
-            </a:pPr>
-            <a:r>
-              <a:t>Entradas: Necesidad de negocio.</a:t>
-            </a:r>
-          </a:p>
-          <a:p>
-            <a:pPr>
-              <a:spcBef>
-                <a:spcPts val="1400"/>
-              </a:spcBef>
-              <a:defRPr sz="2200">
-                <a:solidFill>
-                  <a:srgbClr val="323232"/>
-                </a:solidFill>
-              </a:defRPr>
-            </a:pPr>
-            <a:r>
-              <a:t>• Salidas: Business Case, Acta, Especificación.</a:t>
-            </a:r>
-          </a:p>
-          <a:p>
-            <a:pPr>
-              <a:spcBef>
-                <a:spcPts val="1400"/>
-              </a:spcBef>
-              <a:defRPr sz="2200">
-                <a:solidFill>
-                  <a:srgbClr val="323232"/>
-                </a:solidFill>
-              </a:defRPr>
-            </a:pPr>
-            <a:r>
-              <a:t>• Responsables: Sponsor y PO.</a:t>
-            </a:r>
-          </a:p>
-        </p:txBody>
-      </p:sp>
-    </p:spTree>
-  </p:cSld>
-  <p:clrMapOvr>
-    <a:masterClrMapping/>
-  </p:clrMapOvr>
-</p:sld>
-</file>
-
-<file path=ppt/slides/slide4.xml><?xml version="1.0" encoding="utf-8"?>
-<p:sld xmlns:a="http://schemas.openxmlformats.org/drawingml/2006/main" xmlns:p="http://schemas.openxmlformats.org/presentationml/2006/main" xmlns:r="http://schemas.openxmlformats.org/officeDocument/2006/relationships">
-  <p:cSld>
-    <p:spTree>
-      <p:nvGrpSpPr>
-        <p:cNvPr id="1" name=""/>
-        <p:cNvGrpSpPr/>
-        <p:nvPr/>
-      </p:nvGrpSpPr>
-      <p:grpSpPr/>
-      <p:sp>
-        <p:nvSpPr>
-          <p:cNvPr id="2" name="Rectangle 1"/>
-          <p:cNvSpPr/>
-          <p:nvPr/>
-        </p:nvSpPr>
-        <p:spPr>
-          <a:xfrm>
-            <a:off x="0" y="0"/>
-            <a:ext cx="12191695" cy="1097280"/>
-          </a:xfrm>
-          <a:prstGeom prst="rect">
+          <a:prstGeom prst="rightArrow">
             <a:avLst/>
           </a:prstGeom>
           <a:solidFill>
-            <a:srgbClr val="1E3A5F"/>
+            <a:srgbClr val="CAC5B2"/>
           </a:solidFill>
           <a:ln>
             <a:solidFill>
-              <a:srgbClr val="1E3A5F"/>
+              <a:srgbClr val="CAC5B2"/>
             </a:solidFill>
           </a:ln>
         </p:spPr>
@@ -3686,24 +3576,22 @@
       </p:sp>
       <p:sp>
         <p:nvSpPr>
-          <p:cNvPr id="3" name="Rectangle 2"/>
+          <p:cNvPr id="8" name="Rounded Rectangle 7"/>
           <p:cNvSpPr/>
           <p:nvPr/>
         </p:nvSpPr>
         <p:spPr>
           <a:xfrm>
-            <a:off x="0" y="1097280"/>
-            <a:ext cx="12191695" cy="91440"/>
+            <a:off x="6217920" y="2743200"/>
+            <a:ext cx="1371600" cy="914400"/>
           </a:xfrm>
-          <a:prstGeom prst="rect">
+          <a:prstGeom prst="roundRect">
             <a:avLst/>
           </a:prstGeom>
-          <a:solidFill>
-            <a:srgbClr val="3B82F6"/>
-          </a:solidFill>
-          <a:ln>
+          <a:noFill/>
+          <a:ln w="25400">
             <a:solidFill>
-              <a:srgbClr val="3B82F6"/>
+              <a:srgbClr val="FFFFFF"/>
             </a:solidFill>
           </a:ln>
         </p:spPr>
@@ -3726,105 +3614,13 @@
           <a:lstStyle/>
           <a:p>
             <a:pPr algn="ctr"/>
-          </a:p>
-        </p:txBody>
-      </p:sp>
-      <p:sp>
-        <p:nvSpPr>
-          <p:cNvPr id="4" name="TextBox 3"/>
-          <p:cNvSpPr txBox="1"/>
-          <p:nvPr/>
-        </p:nvSpPr>
-        <p:spPr>
-          <a:xfrm>
-            <a:off x="457200" y="91440"/>
-            <a:ext cx="11277295" cy="914400"/>
-          </a:xfrm>
-          <a:prstGeom prst="rect">
-            <a:avLst/>
-          </a:prstGeom>
-          <a:noFill/>
-        </p:spPr>
-        <p:txBody>
-          <a:bodyPr wrap="none">
-            <a:spAutoFit/>
-          </a:bodyPr>
-          <a:lstStyle/>
-          <a:p>
-            <a:pPr>
-              <a:defRPr b="1" sz="3600">
+            <a:r>
+              <a:rPr sz="1400" b="1">
                 <a:solidFill>
                   <a:srgbClr val="FFFFFF"/>
                 </a:solidFill>
-              </a:defRPr>
-            </a:pPr>
-            <a:r>
-              <a:t>Diseño Arquitectónico</a:t>
-            </a:r>
-          </a:p>
-        </p:txBody>
-      </p:sp>
-      <p:sp>
-        <p:nvSpPr>
-          <p:cNvPr id="5" name="TextBox 4"/>
-          <p:cNvSpPr txBox="1"/>
-          <p:nvPr/>
-        </p:nvSpPr>
-        <p:spPr>
-          <a:xfrm>
-            <a:off x="457200" y="1645920"/>
-            <a:ext cx="11277295" cy="5029200"/>
-          </a:xfrm>
-          <a:prstGeom prst="rect">
-            <a:avLst/>
-          </a:prstGeom>
-          <a:noFill/>
-        </p:spPr>
-        <p:txBody>
-          <a:bodyPr wrap="square">
-            <a:spAutoFit/>
-          </a:bodyPr>
-          <a:lstStyle/>
-          <a:p>
-            <a:pPr>
-              <a:defRPr sz="2200">
-                <a:solidFill>
-                  <a:srgbClr val="323232"/>
-                </a:solidFill>
-              </a:defRPr>
-            </a:pPr>
-            <a:r>
-              <a:t>Entradas: Requerimientos.</a:t>
-            </a:r>
-          </a:p>
-          <a:p>
-            <a:pPr>
-              <a:spcBef>
-                <a:spcPts val="1400"/>
-              </a:spcBef>
-              <a:defRPr sz="2200">
-                <a:solidFill>
-                  <a:srgbClr val="323232"/>
-                </a:solidFill>
-              </a:defRPr>
-            </a:pPr>
-            <a:r>
-              <a:t>• Salidas: Blueprint, ADRs.</a:t>
-            </a:r>
-          </a:p>
-          <a:p>
-            <a:pPr>
-              <a:spcBef>
-                <a:spcPts val="1400"/>
-              </a:spcBef>
-              <a:defRPr sz="2200">
-                <a:solidFill>
-                  <a:srgbClr val="323232"/>
-                </a:solidFill>
-              </a:defRPr>
-            </a:pPr>
-            <a:r>
-              <a:t>• Responsables: Arquitecto de Solución.</a:t>
+              </a:rPr>
+              <a:t>Deploy Staging</a:t>
             </a:r>
           </a:p>
         </p:txBody>
@@ -3837,9 +3633,17 @@
 </p:sld>
 </file>
 
-<file path=ppt/slides/slide5.xml><?xml version="1.0" encoding="utf-8"?>
+<file path=ppt/slides/slide3.xml><?xml version="1.0" encoding="utf-8"?>
 <p:sld xmlns:a="http://schemas.openxmlformats.org/drawingml/2006/main" xmlns:p="http://schemas.openxmlformats.org/presentationml/2006/main" xmlns:r="http://schemas.openxmlformats.org/officeDocument/2006/relationships">
   <p:cSld>
+    <p:bg>
+      <p:bgPr>
+        <a:solidFill>
+          <a:srgbClr val="121212"/>
+        </a:solidFill>
+        <a:effectLst/>
+      </p:bgPr>
+    </p:bg>
     <p:spTree>
       <p:nvGrpSpPr>
         <p:cNvPr id="1" name=""/>
@@ -3849,24 +3653,22 @@
       <p:grpSpPr/>
       <p:sp>
         <p:nvSpPr>
-          <p:cNvPr id="2" name="Rectangle 1"/>
+          <p:cNvPr id="2" name="Rounded Rectangle 1"/>
           <p:cNvSpPr/>
           <p:nvPr/>
         </p:nvSpPr>
         <p:spPr>
           <a:xfrm>
-            <a:off x="0" y="0"/>
-            <a:ext cx="12191695" cy="1097280"/>
+            <a:off x="914400" y="3200400"/>
+            <a:ext cx="1828800" cy="914400"/>
           </a:xfrm>
-          <a:prstGeom prst="rect">
+          <a:prstGeom prst="roundRect">
             <a:avLst/>
           </a:prstGeom>
-          <a:solidFill>
-            <a:srgbClr val="1E3A5F"/>
-          </a:solidFill>
-          <a:ln>
+          <a:noFill/>
+          <a:ln w="25400">
             <a:solidFill>
-              <a:srgbClr val="1E3A5F"/>
+              <a:srgbClr val="CAC5B2"/>
             </a:solidFill>
           </a:ln>
         </p:spPr>
@@ -3889,29 +3691,35 @@
           <a:lstStyle/>
           <a:p>
             <a:pPr algn="ctr"/>
-          </a:p>
-        </p:txBody>
-      </p:sp>
-      <p:sp>
-        <p:nvSpPr>
-          <p:cNvPr id="3" name="Rectangle 2"/>
+            <a:r>
+              <a:rPr sz="1400" b="1">
+                <a:solidFill>
+                  <a:srgbClr val="CAC5B2"/>
+                </a:solidFill>
+              </a:rPr>
+              <a:t>Load Balancer</a:t>
+            </a:r>
+          </a:p>
+        </p:txBody>
+      </p:sp>
+      <p:sp>
+        <p:nvSpPr>
+          <p:cNvPr id="3" name="Rounded Rectangle 2"/>
           <p:cNvSpPr/>
           <p:nvPr/>
         </p:nvSpPr>
         <p:spPr>
           <a:xfrm>
-            <a:off x="0" y="1097280"/>
-            <a:ext cx="12191695" cy="91440"/>
+            <a:off x="4572000" y="1828800"/>
+            <a:ext cx="2743200" cy="1371600"/>
           </a:xfrm>
-          <a:prstGeom prst="rect">
+          <a:prstGeom prst="roundRect">
             <a:avLst/>
           </a:prstGeom>
-          <a:solidFill>
-            <a:srgbClr val="3B82F6"/>
-          </a:solidFill>
-          <a:ln>
+          <a:noFill/>
+          <a:ln w="25400">
             <a:solidFill>
-              <a:srgbClr val="3B82F6"/>
+              <a:srgbClr val="A0A0A0"/>
             </a:solidFill>
           </a:ln>
         </p:spPr>
@@ -3934,132 +3742,48 @@
           <a:lstStyle/>
           <a:p>
             <a:pPr algn="ctr"/>
-          </a:p>
-        </p:txBody>
-      </p:sp>
-      <p:sp>
-        <p:nvSpPr>
-          <p:cNvPr id="4" name="TextBox 3"/>
-          <p:cNvSpPr txBox="1"/>
+            <a:r>
+              <a:rPr sz="1400" b="1">
+                <a:solidFill>
+                  <a:srgbClr val="A0A0A0"/>
+                </a:solidFill>
+              </a:rPr>
+              <a:t>Entorno BLUE (V1)</a:t>
+            </a:r>
+          </a:p>
+          <a:p>
+            <a:pPr algn="ctr"/>
+            <a:r>
+              <a:rPr sz="1400" b="1">
+                <a:solidFill>
+                  <a:srgbClr val="A0A0A0"/>
+                </a:solidFill>
+              </a:rPr>
+              <a:t>(Drenando)</a:t>
+            </a:r>
+          </a:p>
+        </p:txBody>
+      </p:sp>
+      <p:sp>
+        <p:nvSpPr>
+          <p:cNvPr id="4" name="Rounded Rectangle 3"/>
+          <p:cNvSpPr/>
           <p:nvPr/>
         </p:nvSpPr>
         <p:spPr>
           <a:xfrm>
-            <a:off x="457200" y="91440"/>
-            <a:ext cx="11277295" cy="914400"/>
+            <a:off x="4572000" y="4114800"/>
+            <a:ext cx="2743200" cy="1371600"/>
           </a:xfrm>
-          <a:prstGeom prst="rect">
-            <a:avLst/>
-          </a:prstGeom>
-          <a:noFill/>
-        </p:spPr>
-        <p:txBody>
-          <a:bodyPr wrap="none">
-            <a:spAutoFit/>
-          </a:bodyPr>
-          <a:lstStyle/>
-          <a:p>
-            <a:pPr>
-              <a:defRPr b="1" sz="3600">
-                <a:solidFill>
-                  <a:srgbClr val="FFFFFF"/>
-                </a:solidFill>
-              </a:defRPr>
-            </a:pPr>
-            <a:r>
-              <a:t>Construcción y Pruebas</a:t>
-            </a:r>
-          </a:p>
-        </p:txBody>
-      </p:sp>
-      <p:sp>
-        <p:nvSpPr>
-          <p:cNvPr id="5" name="TextBox 4"/>
-          <p:cNvSpPr txBox="1"/>
-          <p:nvPr/>
-        </p:nvSpPr>
-        <p:spPr>
-          <a:xfrm>
-            <a:off x="457200" y="1645920"/>
-            <a:ext cx="11277295" cy="5029200"/>
-          </a:xfrm>
-          <a:prstGeom prst="rect">
-            <a:avLst/>
-          </a:prstGeom>
-          <a:noFill/>
-        </p:spPr>
-        <p:txBody>
-          <a:bodyPr wrap="square">
-            <a:spAutoFit/>
-          </a:bodyPr>
-          <a:lstStyle/>
-          <a:p>
-            <a:pPr>
-              <a:defRPr sz="2200">
-                <a:solidFill>
-                  <a:srgbClr val="323232"/>
-                </a:solidFill>
-              </a:defRPr>
-            </a:pPr>
-            <a:r>
-              <a:t>Verificación Continua (Shift-Left).</a:t>
-            </a:r>
-          </a:p>
-          <a:p>
-            <a:pPr>
-              <a:spcBef>
-                <a:spcPts val="1400"/>
-              </a:spcBef>
-              <a:defRPr sz="2200">
-                <a:solidFill>
-                  <a:srgbClr val="323232"/>
-                </a:solidFill>
-              </a:defRPr>
-            </a:pPr>
-            <a:r>
-              <a:t>• Artefactos: Código, PRs, SAST/DAST, Trazabilidad de Pruebas.</a:t>
-            </a:r>
-          </a:p>
-        </p:txBody>
-      </p:sp>
-    </p:spTree>
-  </p:cSld>
-  <p:clrMapOvr>
-    <a:masterClrMapping/>
-  </p:clrMapOvr>
-</p:sld>
-</file>
-
-<file path=ppt/slides/slide6.xml><?xml version="1.0" encoding="utf-8"?>
-<p:sld xmlns:a="http://schemas.openxmlformats.org/drawingml/2006/main" xmlns:p="http://schemas.openxmlformats.org/presentationml/2006/main" xmlns:r="http://schemas.openxmlformats.org/officeDocument/2006/relationships">
-  <p:cSld>
-    <p:spTree>
-      <p:nvGrpSpPr>
-        <p:cNvPr id="1" name=""/>
-        <p:cNvGrpSpPr/>
-        <p:nvPr/>
-      </p:nvGrpSpPr>
-      <p:grpSpPr/>
-      <p:sp>
-        <p:nvSpPr>
-          <p:cNvPr id="2" name="Rectangle 1"/>
-          <p:cNvSpPr/>
-          <p:nvPr/>
-        </p:nvSpPr>
-        <p:spPr>
-          <a:xfrm>
-            <a:off x="0" y="0"/>
-            <a:ext cx="12191695" cy="1097280"/>
-          </a:xfrm>
-          <a:prstGeom prst="rect">
+          <a:prstGeom prst="roundRect">
             <a:avLst/>
           </a:prstGeom>
           <a:solidFill>
-            <a:srgbClr val="1E3A5F"/>
+            <a:srgbClr val="CAC5B2"/>
           </a:solidFill>
-          <a:ln>
+          <a:ln w="25400">
             <a:solidFill>
-              <a:srgbClr val="1E3A5F"/>
+              <a:srgbClr val="121212"/>
             </a:solidFill>
           </a:ln>
         </p:spPr>
@@ -4082,566 +3806,24 @@
           <a:lstStyle/>
           <a:p>
             <a:pPr algn="ctr"/>
-          </a:p>
-        </p:txBody>
-      </p:sp>
-      <p:sp>
-        <p:nvSpPr>
-          <p:cNvPr id="3" name="Rectangle 2"/>
-          <p:cNvSpPr/>
-          <p:nvPr/>
-        </p:nvSpPr>
-        <p:spPr>
-          <a:xfrm>
-            <a:off x="0" y="1097280"/>
-            <a:ext cx="12191695" cy="91440"/>
-          </a:xfrm>
-          <a:prstGeom prst="rect">
-            <a:avLst/>
-          </a:prstGeom>
-          <a:solidFill>
-            <a:srgbClr val="3B82F6"/>
-          </a:solidFill>
-          <a:ln>
-            <a:solidFill>
-              <a:srgbClr val="3B82F6"/>
-            </a:solidFill>
-          </a:ln>
-        </p:spPr>
-        <p:style>
-          <a:lnRef idx="1">
-            <a:schemeClr val="accent1"/>
-          </a:lnRef>
-          <a:fillRef idx="3">
-            <a:schemeClr val="accent1"/>
-          </a:fillRef>
-          <a:effectRef idx="2">
-            <a:schemeClr val="accent1"/>
-          </a:effectRef>
-          <a:fontRef idx="minor">
-            <a:schemeClr val="lt1"/>
-          </a:fontRef>
-        </p:style>
-        <p:txBody>
-          <a:bodyPr rtlCol="0" anchor="ctr"/>
-          <a:lstStyle/>
+            <a:r>
+              <a:rPr sz="1400" b="1">
+                <a:solidFill>
+                  <a:srgbClr val="121212"/>
+                </a:solidFill>
+              </a:rPr>
+              <a:t>Entorno GREEN (V2)</a:t>
+            </a:r>
+          </a:p>
           <a:p>
             <a:pPr algn="ctr"/>
-          </a:p>
-        </p:txBody>
-      </p:sp>
-      <p:sp>
-        <p:nvSpPr>
-          <p:cNvPr id="4" name="TextBox 3"/>
-          <p:cNvSpPr txBox="1"/>
-          <p:nvPr/>
-        </p:nvSpPr>
-        <p:spPr>
-          <a:xfrm>
-            <a:off x="457200" y="91440"/>
-            <a:ext cx="11277295" cy="914400"/>
-          </a:xfrm>
-          <a:prstGeom prst="rect">
-            <a:avLst/>
-          </a:prstGeom>
-          <a:noFill/>
-        </p:spPr>
-        <p:txBody>
-          <a:bodyPr wrap="none">
-            <a:spAutoFit/>
-          </a:bodyPr>
-          <a:lstStyle/>
-          <a:p>
-            <a:pPr>
-              <a:defRPr b="1" sz="3600">
+            <a:r>
+              <a:rPr sz="1400" b="1">
                 <a:solidFill>
-                  <a:srgbClr val="FFFFFF"/>
+                  <a:srgbClr val="121212"/>
                 </a:solidFill>
-              </a:defRPr>
-            </a:pPr>
-            <a:r>
-              <a:t>Despliegue y Operación</a:t>
-            </a:r>
-          </a:p>
-        </p:txBody>
-      </p:sp>
-      <p:sp>
-        <p:nvSpPr>
-          <p:cNvPr id="5" name="TextBox 4"/>
-          <p:cNvSpPr txBox="1"/>
-          <p:nvPr/>
-        </p:nvSpPr>
-        <p:spPr>
-          <a:xfrm>
-            <a:off x="457200" y="1645920"/>
-            <a:ext cx="11277295" cy="5029200"/>
-          </a:xfrm>
-          <a:prstGeom prst="rect">
-            <a:avLst/>
-          </a:prstGeom>
-          <a:noFill/>
-        </p:spPr>
-        <p:txBody>
-          <a:bodyPr wrap="square">
-            <a:spAutoFit/>
-          </a:bodyPr>
-          <a:lstStyle/>
-          <a:p>
-            <a:pPr>
-              <a:defRPr sz="2200">
-                <a:solidFill>
-                  <a:srgbClr val="323232"/>
-                </a:solidFill>
-              </a:defRPr>
-            </a:pPr>
-            <a:r>
-              <a:t>Entradas: Artefactos firmados.</a:t>
-            </a:r>
-          </a:p>
-          <a:p>
-            <a:pPr>
-              <a:spcBef>
-                <a:spcPts val="1400"/>
-              </a:spcBef>
-              <a:defRPr sz="2200">
-                <a:solidFill>
-                  <a:srgbClr val="323232"/>
-                </a:solidFill>
-              </a:defRPr>
-            </a:pPr>
-            <a:r>
-              <a:t>• Salidas: Runbook, Dashboards, Incidentes.</a:t>
-            </a:r>
-          </a:p>
-          <a:p>
-            <a:pPr>
-              <a:spcBef>
-                <a:spcPts val="1400"/>
-              </a:spcBef>
-              <a:defRPr sz="2200">
-                <a:solidFill>
-                  <a:srgbClr val="323232"/>
-                </a:solidFill>
-              </a:defRPr>
-            </a:pPr>
-            <a:r>
-              <a:t>• Responsables: Release Manager, SRE.</a:t>
-            </a:r>
-          </a:p>
-        </p:txBody>
-      </p:sp>
-    </p:spTree>
-  </p:cSld>
-  <p:clrMapOvr>
-    <a:masterClrMapping/>
-  </p:clrMapOvr>
-</p:sld>
-</file>
-
-<file path=ppt/slides/slide7.xml><?xml version="1.0" encoding="utf-8"?>
-<p:sld xmlns:a="http://schemas.openxmlformats.org/drawingml/2006/main" xmlns:p="http://schemas.openxmlformats.org/presentationml/2006/main" xmlns:r="http://schemas.openxmlformats.org/officeDocument/2006/relationships">
-  <p:cSld>
-    <p:spTree>
-      <p:nvGrpSpPr>
-        <p:cNvPr id="1" name=""/>
-        <p:cNvGrpSpPr/>
-        <p:nvPr/>
-      </p:nvGrpSpPr>
-      <p:grpSpPr/>
-      <p:sp>
-        <p:nvSpPr>
-          <p:cNvPr id="2" name="Rectangle 1"/>
-          <p:cNvSpPr/>
-          <p:nvPr/>
-        </p:nvSpPr>
-        <p:spPr>
-          <a:xfrm>
-            <a:off x="0" y="0"/>
-            <a:ext cx="12191695" cy="1097280"/>
-          </a:xfrm>
-          <a:prstGeom prst="rect">
-            <a:avLst/>
-          </a:prstGeom>
-          <a:solidFill>
-            <a:srgbClr val="1E3A5F"/>
-          </a:solidFill>
-          <a:ln>
-            <a:solidFill>
-              <a:srgbClr val="1E3A5F"/>
-            </a:solidFill>
-          </a:ln>
-        </p:spPr>
-        <p:style>
-          <a:lnRef idx="1">
-            <a:schemeClr val="accent1"/>
-          </a:lnRef>
-          <a:fillRef idx="3">
-            <a:schemeClr val="accent1"/>
-          </a:fillRef>
-          <a:effectRef idx="2">
-            <a:schemeClr val="accent1"/>
-          </a:effectRef>
-          <a:fontRef idx="minor">
-            <a:schemeClr val="lt1"/>
-          </a:fontRef>
-        </p:style>
-        <p:txBody>
-          <a:bodyPr rtlCol="0" anchor="ctr"/>
-          <a:lstStyle/>
-          <a:p>
-            <a:pPr algn="ctr"/>
-          </a:p>
-        </p:txBody>
-      </p:sp>
-      <p:sp>
-        <p:nvSpPr>
-          <p:cNvPr id="3" name="Rectangle 2"/>
-          <p:cNvSpPr/>
-          <p:nvPr/>
-        </p:nvSpPr>
-        <p:spPr>
-          <a:xfrm>
-            <a:off x="0" y="1097280"/>
-            <a:ext cx="12191695" cy="91440"/>
-          </a:xfrm>
-          <a:prstGeom prst="rect">
-            <a:avLst/>
-          </a:prstGeom>
-          <a:solidFill>
-            <a:srgbClr val="3B82F6"/>
-          </a:solidFill>
-          <a:ln>
-            <a:solidFill>
-              <a:srgbClr val="3B82F6"/>
-            </a:solidFill>
-          </a:ln>
-        </p:spPr>
-        <p:style>
-          <a:lnRef idx="1">
-            <a:schemeClr val="accent1"/>
-          </a:lnRef>
-          <a:fillRef idx="3">
-            <a:schemeClr val="accent1"/>
-          </a:fillRef>
-          <a:effectRef idx="2">
-            <a:schemeClr val="accent1"/>
-          </a:effectRef>
-          <a:fontRef idx="minor">
-            <a:schemeClr val="lt1"/>
-          </a:fontRef>
-        </p:style>
-        <p:txBody>
-          <a:bodyPr rtlCol="0" anchor="ctr"/>
-          <a:lstStyle/>
-          <a:p>
-            <a:pPr algn="ctr"/>
-          </a:p>
-        </p:txBody>
-      </p:sp>
-      <p:sp>
-        <p:nvSpPr>
-          <p:cNvPr id="4" name="TextBox 3"/>
-          <p:cNvSpPr txBox="1"/>
-          <p:nvPr/>
-        </p:nvSpPr>
-        <p:spPr>
-          <a:xfrm>
-            <a:off x="457200" y="91440"/>
-            <a:ext cx="11277295" cy="914400"/>
-          </a:xfrm>
-          <a:prstGeom prst="rect">
-            <a:avLst/>
-          </a:prstGeom>
-          <a:noFill/>
-        </p:spPr>
-        <p:txBody>
-          <a:bodyPr wrap="none">
-            <a:spAutoFit/>
-          </a:bodyPr>
-          <a:lstStyle/>
-          <a:p>
-            <a:pPr>
-              <a:defRPr b="1" sz="3600">
-                <a:solidFill>
-                  <a:srgbClr val="FFFFFF"/>
-                </a:solidFill>
-              </a:defRPr>
-            </a:pPr>
-            <a:r>
-              <a:t>Retiro y Sunset</a:t>
-            </a:r>
-          </a:p>
-        </p:txBody>
-      </p:sp>
-      <p:sp>
-        <p:nvSpPr>
-          <p:cNvPr id="5" name="TextBox 4"/>
-          <p:cNvSpPr txBox="1"/>
-          <p:nvPr/>
-        </p:nvSpPr>
-        <p:spPr>
-          <a:xfrm>
-            <a:off x="457200" y="1645920"/>
-            <a:ext cx="11277295" cy="5029200"/>
-          </a:xfrm>
-          <a:prstGeom prst="rect">
-            <a:avLst/>
-          </a:prstGeom>
-          <a:noFill/>
-        </p:spPr>
-        <p:txBody>
-          <a:bodyPr wrap="square">
-            <a:spAutoFit/>
-          </a:bodyPr>
-          <a:lstStyle/>
-          <a:p>
-            <a:pPr>
-              <a:defRPr sz="2200">
-                <a:solidFill>
-                  <a:srgbClr val="323232"/>
-                </a:solidFill>
-              </a:defRPr>
-            </a:pPr>
-            <a:r>
-              <a:t>Desconexión gobernada.</a:t>
-            </a:r>
-          </a:p>
-          <a:p>
-            <a:pPr>
-              <a:spcBef>
-                <a:spcPts val="1400"/>
-              </a:spcBef>
-              <a:defRPr sz="2200">
-                <a:solidFill>
-                  <a:srgbClr val="323232"/>
-                </a:solidFill>
-              </a:defRPr>
-            </a:pPr>
-            <a:r>
-              <a:t>• Artefactos: Plan de Retiro, Checklist.</a:t>
-            </a:r>
-          </a:p>
-        </p:txBody>
-      </p:sp>
-    </p:spTree>
-  </p:cSld>
-  <p:clrMapOvr>
-    <a:masterClrMapping/>
-  </p:clrMapOvr>
-</p:sld>
-</file>
-
-<file path=ppt/slides/slide8.xml><?xml version="1.0" encoding="utf-8"?>
-<p:sld xmlns:a="http://schemas.openxmlformats.org/drawingml/2006/main" xmlns:p="http://schemas.openxmlformats.org/presentationml/2006/main" xmlns:r="http://schemas.openxmlformats.org/officeDocument/2006/relationships">
-  <p:cSld>
-    <p:spTree>
-      <p:nvGrpSpPr>
-        <p:cNvPr id="1" name=""/>
-        <p:cNvGrpSpPr/>
-        <p:nvPr/>
-      </p:nvGrpSpPr>
-      <p:grpSpPr/>
-      <p:sp>
-        <p:nvSpPr>
-          <p:cNvPr id="2" name="Rectangle 1"/>
-          <p:cNvSpPr/>
-          <p:nvPr/>
-        </p:nvSpPr>
-        <p:spPr>
-          <a:xfrm>
-            <a:off x="0" y="0"/>
-            <a:ext cx="12191695" cy="1097280"/>
-          </a:xfrm>
-          <a:prstGeom prst="rect">
-            <a:avLst/>
-          </a:prstGeom>
-          <a:solidFill>
-            <a:srgbClr val="1E3A5F"/>
-          </a:solidFill>
-          <a:ln>
-            <a:solidFill>
-              <a:srgbClr val="1E3A5F"/>
-            </a:solidFill>
-          </a:ln>
-        </p:spPr>
-        <p:style>
-          <a:lnRef idx="1">
-            <a:schemeClr val="accent1"/>
-          </a:lnRef>
-          <a:fillRef idx="3">
-            <a:schemeClr val="accent1"/>
-          </a:fillRef>
-          <a:effectRef idx="2">
-            <a:schemeClr val="accent1"/>
-          </a:effectRef>
-          <a:fontRef idx="minor">
-            <a:schemeClr val="lt1"/>
-          </a:fontRef>
-        </p:style>
-        <p:txBody>
-          <a:bodyPr rtlCol="0" anchor="ctr"/>
-          <a:lstStyle/>
-          <a:p>
-            <a:pPr algn="ctr"/>
-          </a:p>
-        </p:txBody>
-      </p:sp>
-      <p:sp>
-        <p:nvSpPr>
-          <p:cNvPr id="3" name="Rectangle 2"/>
-          <p:cNvSpPr/>
-          <p:nvPr/>
-        </p:nvSpPr>
-        <p:spPr>
-          <a:xfrm>
-            <a:off x="0" y="1097280"/>
-            <a:ext cx="12191695" cy="91440"/>
-          </a:xfrm>
-          <a:prstGeom prst="rect">
-            <a:avLst/>
-          </a:prstGeom>
-          <a:solidFill>
-            <a:srgbClr val="3B82F6"/>
-          </a:solidFill>
-          <a:ln>
-            <a:solidFill>
-              <a:srgbClr val="3B82F6"/>
-            </a:solidFill>
-          </a:ln>
-        </p:spPr>
-        <p:style>
-          <a:lnRef idx="1">
-            <a:schemeClr val="accent1"/>
-          </a:lnRef>
-          <a:fillRef idx="3">
-            <a:schemeClr val="accent1"/>
-          </a:fillRef>
-          <a:effectRef idx="2">
-            <a:schemeClr val="accent1"/>
-          </a:effectRef>
-          <a:fontRef idx="minor">
-            <a:schemeClr val="lt1"/>
-          </a:fontRef>
-        </p:style>
-        <p:txBody>
-          <a:bodyPr rtlCol="0" anchor="ctr"/>
-          <a:lstStyle/>
-          <a:p>
-            <a:pPr algn="ctr"/>
-          </a:p>
-        </p:txBody>
-      </p:sp>
-      <p:sp>
-        <p:nvSpPr>
-          <p:cNvPr id="4" name="TextBox 3"/>
-          <p:cNvSpPr txBox="1"/>
-          <p:nvPr/>
-        </p:nvSpPr>
-        <p:spPr>
-          <a:xfrm>
-            <a:off x="457200" y="91440"/>
-            <a:ext cx="11277295" cy="914400"/>
-          </a:xfrm>
-          <a:prstGeom prst="rect">
-            <a:avLst/>
-          </a:prstGeom>
-          <a:noFill/>
-        </p:spPr>
-        <p:txBody>
-          <a:bodyPr wrap="none">
-            <a:spAutoFit/>
-          </a:bodyPr>
-          <a:lstStyle/>
-          <a:p>
-            <a:pPr>
-              <a:defRPr b="1" sz="3600">
-                <a:solidFill>
-                  <a:srgbClr val="FFFFFF"/>
-                </a:solidFill>
-              </a:defRPr>
-            </a:pPr>
-            <a:r>
-              <a:t>Timeline de Aplicación</a:t>
-            </a:r>
-          </a:p>
-        </p:txBody>
-      </p:sp>
-      <p:sp>
-        <p:nvSpPr>
-          <p:cNvPr id="5" name="TextBox 4"/>
-          <p:cNvSpPr txBox="1"/>
-          <p:nvPr/>
-        </p:nvSpPr>
-        <p:spPr>
-          <a:xfrm>
-            <a:off x="457200" y="1645920"/>
-            <a:ext cx="11277295" cy="5029200"/>
-          </a:xfrm>
-          <a:prstGeom prst="rect">
-            <a:avLst/>
-          </a:prstGeom>
-          <a:noFill/>
-        </p:spPr>
-        <p:txBody>
-          <a:bodyPr wrap="square">
-            <a:spAutoFit/>
-          </a:bodyPr>
-          <a:lstStyle/>
-          <a:p>
-            <a:pPr>
-              <a:defRPr sz="2200">
-                <a:solidFill>
-                  <a:srgbClr val="323232"/>
-                </a:solidFill>
-              </a:defRPr>
-            </a:pPr>
-            <a:r>
-              <a:t>M1: Ideación/Análisis</a:t>
-            </a:r>
-          </a:p>
-          <a:p>
-            <a:pPr>
-              <a:spcBef>
-                <a:spcPts val="1400"/>
-              </a:spcBef>
-              <a:defRPr sz="2200">
-                <a:solidFill>
-                  <a:srgbClr val="323232"/>
-                </a:solidFill>
-              </a:defRPr>
-            </a:pPr>
-            <a:r>
-              <a:t>• M2: Diseño</a:t>
-            </a:r>
-          </a:p>
-          <a:p>
-            <a:pPr>
-              <a:spcBef>
-                <a:spcPts val="1400"/>
-              </a:spcBef>
-              <a:defRPr sz="2200">
-                <a:solidFill>
-                  <a:srgbClr val="323232"/>
-                </a:solidFill>
-              </a:defRPr>
-            </a:pPr>
-            <a:r>
-              <a:t>• M3-4: Sprints</a:t>
-            </a:r>
-          </a:p>
-          <a:p>
-            <a:pPr>
-              <a:spcBef>
-                <a:spcPts val="1400"/>
-              </a:spcBef>
-              <a:defRPr sz="2200">
-                <a:solidFill>
-                  <a:srgbClr val="323232"/>
-                </a:solidFill>
-              </a:defRPr>
-            </a:pPr>
-            <a:r>
-              <a:t>• M5: Pruebas y Despliegue</a:t>
+              </a:rPr>
+              <a:t>(Tráfico Activo)</a:t>
             </a:r>
           </a:p>
         </p:txBody>

</xml_diff>